<commit_message>
Redact student number and AWS account ID from report deliverables
Replaced the student number (CCA5008) and AWS account ID
(477013660512) with REDACTED across both PDFs, both docx copies,
all three pptx copies, the two generator scripts, and the two
week checklist files that still referenced the account number.
</commit_message>
<xml_diff>
--- a/SOCWatch-Evidence/SOCWatch-Evidence/report/SOCWatch-Presentation-Draft.pptx
+++ b/SOCWatch-Evidence/SOCWatch-Evidence/report/SOCWatch-Presentation-Draft.pptx
@@ -2130,7 +2130,7 @@
                 <a:ea typeface="Calibri" pitchFamily="34" charset="-122"/>
                 <a:cs typeface="Calibri" pitchFamily="34" charset="-120"/>
               </a:rPr>
-              <a:t>Student Number: CCA5008</a:t>
+              <a:t>Student Number: REDACTED</a:t>
             </a:r>
             <a:endParaRPr lang="en-US" sz="1400" dirty="0"/>
           </a:p>
@@ -3624,7 +3624,7 @@
                 <a:ea typeface="Calibri" pitchFamily="34" charset="-122"/>
                 <a:cs typeface="Calibri" pitchFamily="34" charset="-120"/>
               </a:rPr>
-              <a:t>Contact: Nishen Madawa Abedeera (CCA5008) | nishenmadawa15@gmail.com</a:t>
+              <a:t>Contact: Nishen Madawa Abedeera (REDACTED) | nishenmadawa15@gmail.com</a:t>
             </a:r>
             <a:endParaRPr lang="en-US" sz="1400" dirty="0"/>
           </a:p>

</xml_diff>